<commit_message>
Docs: add repository link to the post kit and the final slide
Co-Authored-By: Claude Sonnet 5.5 <noreply@anthropic.com>
</commit_message>
<xml_diff>
--- a/docs/LensMate_presentation.pptx
+++ b/docs/LensMate_presentation.pptx
@@ -115,26 +115,26 @@
   <p:extLst>
     <p:ext uri="{521415D9-36F7-43E2-AB2F-B90AF26B5E84}">
       <p14:sectionLst xmlns:p14="http://schemas.microsoft.com/office/powerpoint/2010/main">
-        <p14:section name="Intro" id="{4f84d7ff-8f26-bbca-822e-62b9a39fdbaa}">
+        <p14:section name="Intro" id="{6f225b56-e48d-8968-31cd-5c7babef1bdd}">
           <p14:sldIdLst>
             <p14:sldId id="256"/>
             <p14:sldId id="257"/>
           </p14:sldIdLst>
         </p14:section>
-        <p14:section name="Product" id="{ec54ede6-53e7-3fec-2f21-6098800ede51}">
+        <p14:section name="Product" id="{fca470ad-a45e-6776-21ba-ba3fd7254cd0}">
           <p14:sldIdLst>
             <p14:sldId id="258"/>
             <p14:sldId id="259"/>
             <p14:sldId id="260"/>
           </p14:sldIdLst>
         </p14:section>
-        <p14:section name="Engineering" id="{f182aaa4-3dfd-5676-2625-be2f0a089785}">
+        <p14:section name="Engineering" id="{ad2ce4a0-3691-880c-efad-f11b0977b9a8}">
           <p14:sldIdLst>
             <p14:sldId id="261"/>
             <p14:sldId id="262"/>
           </p14:sldIdLst>
         </p14:section>
-        <p14:section name="Wrap-up" id="{1277630d-b56f-1a6d-0d28-80cc6298f14a}">
+        <p14:section name="Wrap-up" id="{cbb6a65d-ceac-22ec-fd24-356ea2684f1d}">
           <p14:sldIdLst>
             <p14:sldId id="263"/>
             <p14:sldId id="264"/>
@@ -1553,7 +1553,7 @@
           <a:p>
             <a:r>
               <a:rPr lang="en-US" dirty="0"/>
-              <a:t>[0:30] Three takeaways. Measure, do not assume: every real problem showed up in a number. Teaching beats swapping models: one photo fixed what a newer model did not. Use code where the model is blind. The code, the benchmarks and the design notes are on GitHub. Questions. (Add the GitHub address to the closing line before presenting.)</a:t>
+              <a:t>[0:30] Three takeaways. Measure, do not assume: every real problem showed up in a number. Teaching beats swapping models: one photo fixed what a newer model did not. Use code where the model is blind. The code, the benchmarks and the design notes are on GitHub at vashistavarma slash lensmate. Questions.</a:t>
             </a:r>
             <a:endParaRPr lang="en-US" dirty="0"/>
           </a:p>
@@ -9276,8 +9276,8 @@
         </p:nvSpPr>
         <p:spPr>
           <a:xfrm>
-            <a:off x="4754880" y="5166360"/>
-            <a:ext cx="6583680" cy="914400"/>
+            <a:off x="4480560" y="5166360"/>
+            <a:ext cx="6949440" cy="914400"/>
           </a:xfrm>
           <a:prstGeom prst="rect">
             <a:avLst/>
@@ -9298,7 +9298,7 @@
                   <a:schemeClr val="tx1"/>
                 </a:solidFill>
               </a:rPr>
-              <a:t>Code, benchmarks and design notes are on GitHub.</a:t>
+              <a:t>Code, benchmarks and design notes: github.com/vashistavarma/lensmate</a:t>
             </a:r>
             <a:endParaRPr lang="en-US" sz="1800" dirty="0"/>
           </a:p>

</xml_diff>

<commit_message>
Docs: report speech WER and visual-memory results as ranges, add latency-cache note
Repeated runs showed offline speech WER of 2-4% (always the 'mecanum' sentence) and
visual-memory recognition of 5/6 to 6/6 across three runs; deck, diagram, README and
design notes updated to match.

Co-Authored-By: Claude Sonnet 5.5 <noreply@anthropic.com>
</commit_message>
<xml_diff>
--- a/docs/LensMate_presentation.pptx
+++ b/docs/LensMate_presentation.pptx
@@ -115,26 +115,26 @@
   <p:extLst>
     <p:ext uri="{521415D9-36F7-43E2-AB2F-B90AF26B5E84}">
       <p14:sectionLst xmlns:p14="http://schemas.microsoft.com/office/powerpoint/2010/main">
-        <p14:section name="Intro" id="{6f225b56-e48d-8968-31cd-5c7babef1bdd}">
+        <p14:section name="Intro" id="{6e6a217d-4264-579f-7fe2-c64ccc3eb00f}">
           <p14:sldIdLst>
             <p14:sldId id="256"/>
             <p14:sldId id="257"/>
           </p14:sldIdLst>
         </p14:section>
-        <p14:section name="Product" id="{fca470ad-a45e-6776-21ba-ba3fd7254cd0}">
+        <p14:section name="Product" id="{7031e06a-838f-6e5e-b72c-40988732d1d6}">
           <p14:sldIdLst>
             <p14:sldId id="258"/>
             <p14:sldId id="259"/>
             <p14:sldId id="260"/>
           </p14:sldIdLst>
         </p14:section>
-        <p14:section name="Engineering" id="{ad2ce4a0-3691-880c-efad-f11b0977b9a8}">
+        <p14:section name="Engineering" id="{2385cd2a-fc8f-e730-415c-8d71550224f6}">
           <p14:sldIdLst>
             <p14:sldId id="261"/>
             <p14:sldId id="262"/>
           </p14:sldIdLst>
         </p14:section>
-        <p14:section name="Wrap-up" id="{cbb6a65d-ceac-22ec-fd24-356ea2684f1d}">
+        <p14:section name="Wrap-up" id="{4c43c1cf-4fec-b94a-2e9f-a5dc40752652}">
           <p14:sldIdLst>
             <p14:sldId id="263"/>
             <p14:sldId id="264"/>
@@ -278,10 +278,10 @@
                     <c:v>Unaided (1/8)</c:v>
                   </c:pt>
                   <c:pt idx="1">
-                    <c:v>Taught photo (5/6)</c:v>
+                    <c:v>Taught (5/6)</c:v>
                   </c:pt>
                   <c:pt idx="2">
-                    <c:v>Taught photo (6/6)</c:v>
+                    <c:v>Taught, best (6/6)</c:v>
                   </c:pt>
                 </c:lvl>
               </c:multiLvlStrCache>
@@ -1377,7 +1377,7 @@
           <a:p>
             <a:r>
               <a:rPr lang="en-US" dirty="0"/>
-              <a:t>[1:00] The headline: unaided, the 7B model named my niche hardware, a mecanum wheel and a motor driver, correctly 1 time in 8. With a taught photo, held-out photos were recognised 5 of 6 and 6 of 6 in two runs, with zero false claims across 10 negative tests. Box overlap is 0.96, actions pass 6 of 6 on synthetic clips, and giving Whisper the taught names cut its error from 4 percent to 0. I want to be clear these are small samples, and the action and speech tests used synthetic input.</a:t>
+              <a:t>[1:00] The headline: unaided, the 7B model named my niche hardware, a mecanum wheel and a motor driver, correctly 1 time in 8. With a taught photo, held-out photos were recognised 5 or 6 of 6 across three runs, with zero false claims across 10 negative tests. Box overlap is 0.96, actions pass 6 of 6 on synthetic clips, and giving Whisper the taught names cut its error from 2 to 4 percent down to 0. I want to be clear these are small samples, and the action and speech tests used synthetic input.</a:t>
             </a:r>
             <a:endParaRPr lang="en-US" dirty="0"/>
           </a:p>
@@ -8185,7 +8185,7 @@
                   <a:schemeClr val="accent1"/>
                 </a:solidFill>
               </a:rPr>
-              <a:t>4% → 0%</a:t>
+              <a:t>0%</a:t>
             </a:r>
             <a:endParaRPr lang="en-US" sz="3400" dirty="0"/>
           </a:p>
@@ -8221,7 +8221,7 @@
                   <a:schemeClr val="tx1"/>
                 </a:solidFill>
               </a:rPr>
-              <a:t>offline speech errors with taught-name hints</a:t>
+              <a:t>speech errors with taught-name hints (up to 4% without)</a:t>
             </a:r>
             <a:endParaRPr lang="en-US" sz="1400" dirty="0"/>
           </a:p>

</xml_diff>

<commit_message>
Split public/private: this repo is the full private one; update docs and deck for a front-end-only public repo
Co-Authored-By: Claude Sonnet 5.5 <noreply@anthropic.com>
</commit_message>
<xml_diff>
--- a/docs/LensMate_presentation.pptx
+++ b/docs/LensMate_presentation.pptx
@@ -115,26 +115,26 @@
   <p:extLst>
     <p:ext uri="{521415D9-36F7-43E2-AB2F-B90AF26B5E84}">
       <p14:sectionLst xmlns:p14="http://schemas.microsoft.com/office/powerpoint/2010/main">
-        <p14:section name="Intro" id="{6e6a217d-4264-579f-7fe2-c64ccc3eb00f}">
+        <p14:section name="Intro" id="{176df3c0-1fb8-8882-14ae-ef5eed2bf892}">
           <p14:sldIdLst>
             <p14:sldId id="256"/>
             <p14:sldId id="257"/>
           </p14:sldIdLst>
         </p14:section>
-        <p14:section name="Product" id="{7031e06a-838f-6e5e-b72c-40988732d1d6}">
+        <p14:section name="Product" id="{008ea0f7-1757-69db-29e2-a7056100ff32}">
           <p14:sldIdLst>
             <p14:sldId id="258"/>
             <p14:sldId id="259"/>
             <p14:sldId id="260"/>
           </p14:sldIdLst>
         </p14:section>
-        <p14:section name="Engineering" id="{2385cd2a-fc8f-e730-415c-8d71550224f6}">
+        <p14:section name="Engineering" id="{1fd230e6-0dc4-7bd9-118a-8c84dd137cd3}">
           <p14:sldIdLst>
             <p14:sldId id="261"/>
             <p14:sldId id="262"/>
           </p14:sldIdLst>
         </p14:section>
-        <p14:section name="Wrap-up" id="{4c43c1cf-4fec-b94a-2e9f-a5dc40752652}">
+        <p14:section name="Wrap-up" id="{688db866-fe69-48d8-3341-16a3c428589e}">
           <p14:sldIdLst>
             <p14:sldId id="263"/>
             <p14:sldId id="264"/>
@@ -1289,7 +1289,7 @@
           <a:p>
             <a:r>
               <a:rPr lang="en-US" dirty="0"/>
-              <a:t>[1:30] The most useful part of the project was measuring what broke. One: my boxes were 1.2 times too big because Ollama resizes images before the model sees them. Two: putting reference photos in the prompt made the model claim matches on every unrelated image; a separate yes/no check per photo fixed it. Three: the model cannot follow motion across frames, it called left-to-right motion circular rotation, so I measure motion in code and let the model name the moving thing. Four: a newer model scored 0 of 8 and was six times slower, so I kept the older one. All of this is in docs/DESIGN_NOTES.md.</a:t>
+              <a:t>[1:30] The most useful part of the project was measuring what broke. One: my boxes were 1.2 times too big because Ollama resizes images before the model sees them. Two: putting reference photos in the prompt made the model claim matches on every unrelated image; a separate yes/no check per photo fixed it. Three: the model cannot follow motion across frames, it called left-to-right motion circular rotation, so I measure motion in code and let the model name the moving thing. Four: a newer model scored 0 of 8 and was six times slower, so I kept the older one.</a:t>
             </a:r>
             <a:endParaRPr lang="en-US" dirty="0"/>
           </a:p>
@@ -1553,7 +1553,7 @@
           <a:p>
             <a:r>
               <a:rPr lang="en-US" dirty="0"/>
-              <a:t>[0:30] Three takeaways. Measure, do not assume: every real problem showed up in a number. Teaching beats swapping models: one photo fixed what a newer model did not. Use code where the model is blind. The code, the benchmarks and the design notes are on GitHub at vashistavarma slash lensmate. Questions.</a:t>
+              <a:t>[0:30] Three takeaways. Measure, do not assume: every real problem showed up in a number. Teaching beats swapping models: one photo fixed what a newer model did not. Use code where the model is blind. The front-end code is on GitHub at vashistavarma slash lensmate; the model server and evaluation code stay private. Questions.</a:t>
             </a:r>
             <a:endParaRPr lang="en-US" dirty="0"/>
           </a:p>
@@ -9298,7 +9298,7 @@
                   <a:schemeClr val="tx1"/>
                 </a:solidFill>
               </a:rPr>
-              <a:t>Code, benchmarks and design notes: github.com/vashistavarma/lensmate</a:t>
+              <a:t>Front-end code and demo: github.com/vashistavarma/lensmate</a:t>
             </a:r>
             <a:endParaRPr lang="en-US" sz="1800" dirty="0"/>
           </a:p>

</xml_diff>

<commit_message>
Revert the public/private split: GitHub stays as it is (full public repo)
Co-Authored-By: Claude Sonnet 5.5 <noreply@anthropic.com>
</commit_message>
<xml_diff>
--- a/docs/LensMate_presentation.pptx
+++ b/docs/LensMate_presentation.pptx
@@ -115,26 +115,26 @@
   <p:extLst>
     <p:ext uri="{521415D9-36F7-43E2-AB2F-B90AF26B5E84}">
       <p14:sectionLst xmlns:p14="http://schemas.microsoft.com/office/powerpoint/2010/main">
-        <p14:section name="Intro" id="{176df3c0-1fb8-8882-14ae-ef5eed2bf892}">
+        <p14:section name="Intro" id="{6e6a217d-4264-579f-7fe2-c64ccc3eb00f}">
           <p14:sldIdLst>
             <p14:sldId id="256"/>
             <p14:sldId id="257"/>
           </p14:sldIdLst>
         </p14:section>
-        <p14:section name="Product" id="{008ea0f7-1757-69db-29e2-a7056100ff32}">
+        <p14:section name="Product" id="{7031e06a-838f-6e5e-b72c-40988732d1d6}">
           <p14:sldIdLst>
             <p14:sldId id="258"/>
             <p14:sldId id="259"/>
             <p14:sldId id="260"/>
           </p14:sldIdLst>
         </p14:section>
-        <p14:section name="Engineering" id="{1fd230e6-0dc4-7bd9-118a-8c84dd137cd3}">
+        <p14:section name="Engineering" id="{2385cd2a-fc8f-e730-415c-8d71550224f6}">
           <p14:sldIdLst>
             <p14:sldId id="261"/>
             <p14:sldId id="262"/>
           </p14:sldIdLst>
         </p14:section>
-        <p14:section name="Wrap-up" id="{688db866-fe69-48d8-3341-16a3c428589e}">
+        <p14:section name="Wrap-up" id="{4c43c1cf-4fec-b94a-2e9f-a5dc40752652}">
           <p14:sldIdLst>
             <p14:sldId id="263"/>
             <p14:sldId id="264"/>
@@ -1289,7 +1289,7 @@
           <a:p>
             <a:r>
               <a:rPr lang="en-US" dirty="0"/>
-              <a:t>[1:30] The most useful part of the project was measuring what broke. One: my boxes were 1.2 times too big because Ollama resizes images before the model sees them. Two: putting reference photos in the prompt made the model claim matches on every unrelated image; a separate yes/no check per photo fixed it. Three: the model cannot follow motion across frames, it called left-to-right motion circular rotation, so I measure motion in code and let the model name the moving thing. Four: a newer model scored 0 of 8 and was six times slower, so I kept the older one.</a:t>
+              <a:t>[1:30] The most useful part of the project was measuring what broke. One: my boxes were 1.2 times too big because Ollama resizes images before the model sees them. Two: putting reference photos in the prompt made the model claim matches on every unrelated image; a separate yes/no check per photo fixed it. Three: the model cannot follow motion across frames, it called left-to-right motion circular rotation, so I measure motion in code and let the model name the moving thing. Four: a newer model scored 0 of 8 and was six times slower, so I kept the older one. All of this is in docs/DESIGN_NOTES.md.</a:t>
             </a:r>
             <a:endParaRPr lang="en-US" dirty="0"/>
           </a:p>
@@ -1553,7 +1553,7 @@
           <a:p>
             <a:r>
               <a:rPr lang="en-US" dirty="0"/>
-              <a:t>[0:30] Three takeaways. Measure, do not assume: every real problem showed up in a number. Teaching beats swapping models: one photo fixed what a newer model did not. Use code where the model is blind. The front-end code is on GitHub at vashistavarma slash lensmate; the model server and evaluation code stay private. Questions.</a:t>
+              <a:t>[0:30] Three takeaways. Measure, do not assume: every real problem showed up in a number. Teaching beats swapping models: one photo fixed what a newer model did not. Use code where the model is blind. The code, the benchmarks and the design notes are on GitHub at vashistavarma slash lensmate. Questions.</a:t>
             </a:r>
             <a:endParaRPr lang="en-US" dirty="0"/>
           </a:p>
@@ -9298,7 +9298,7 @@
                   <a:schemeClr val="tx1"/>
                 </a:solidFill>
               </a:rPr>
-              <a:t>Front-end code and demo: github.com/vashistavarma/lensmate</a:t>
+              <a:t>Code, benchmarks and design notes: github.com/vashistavarma/lensmate</a:t>
             </a:r>
             <a:endParaRPr lang="en-US" sz="1800" dirty="0"/>
           </a:p>

</xml_diff>